<commit_message>
Remove personal identifiers from website
</commit_message>
<xml_diff>
--- a/assets/Digitalverse_Onboarding_Agenda_FixElectrical_v3.pptx
+++ b/assets/Digitalverse_Onboarding_Agenda_FixElectrical_v3.pptx
@@ -7837,7 +7837,7 @@
                   <a:srgbClr val="F5F7FA"/>
                 </a:solidFill>
               </a:rPr>
-              <a:t>Consultant — Simon De Greyte</a:t>
+              <a:t>Consultant — Digitalverse consultant</a:t>
             </a:r>
           </a:p>
           <a:p>
@@ -7863,7 +7863,7 @@
                   <a:srgbClr val="F5F7FA"/>
                 </a:solidFill>
               </a:rPr>
-              <a:t>Consultant — Victoria De Greyte</a:t>
+              <a:t>Consultant — Digitalverse consultant</a:t>
             </a:r>
           </a:p>
           <a:p>

</xml_diff>